<commit_message>
Regenerate presentation with valid Chinese text
</commit_message>
<xml_diff>
--- a/a_share_shortline_watchlist_20260608.pptx
+++ b/a_share_shortline_watchlist_20260608.pptx
@@ -3135,7 +3135,7 @@
                 </a:solidFill>
                 <a:latin typeface="Microsoft YaHei"/>
               </a:rPr>
-              <a:t>A??????????????</a:t>
+              <a:t>A股短线主线与“龙回头”观察池</a:t>
             </a:r>
           </a:p>
         </p:txBody>
@@ -3149,7 +3149,7 @@
         <p:spPr>
           <a:xfrm>
             <a:off x="685800" y="1691640"/>
-            <a:ext cx="9144000" cy="411480"/>
+            <a:ext cx="9692640" cy="411480"/>
           </a:xfrm>
           <a:prstGeom prst="rect">
             <a:avLst/>
@@ -3166,11 +3166,11 @@
             <a:r>
               <a:rPr sz="1500" b="0">
                 <a:solidFill>
-                  <a:srgbClr val="D5DADD"/>
-                </a:solidFill>
-                <a:latin typeface="Microsoft YaHei"/>
-              </a:rPr>
-              <a:t>2026-06-08 ??????????????????????</a:t>
+                  <a:srgbClr val="E6EAEC"/>
+                </a:solidFill>
+                <a:latin typeface="Microsoft YaHei"/>
+              </a:rPr>
+              <a:t>2026-06-08 盘前作战报告｜非龙头不炒、右侧确认、纪律止损</a:t>
             </a:r>
           </a:p>
         </p:txBody>
@@ -3228,7 +3228,7 @@
         </p:nvSpPr>
         <p:spPr>
           <a:xfrm>
-            <a:off x="822960" y="2926080"/>
+            <a:off x="822960" y="2907792"/>
             <a:ext cx="2103120" cy="411480"/>
           </a:xfrm>
           <a:prstGeom prst="rect">
@@ -3285,7 +3285,7 @@
                 </a:solidFill>
                 <a:latin typeface="Microsoft YaHei"/>
               </a:rPr>
-              <a:t>????</a:t>
+              <a:t>上证指数</a:t>
             </a:r>
           </a:p>
         </p:txBody>
@@ -3320,7 +3320,7 @@
                 </a:solidFill>
                 <a:latin typeface="Microsoft YaHei"/>
               </a:rPr>
-              <a:t>?????????-0.74%</a:t>
+              <a:t>东方财富盘前展示：-0.74%</a:t>
             </a:r>
           </a:p>
         </p:txBody>
@@ -3378,7 +3378,7 @@
         </p:nvSpPr>
         <p:spPr>
           <a:xfrm>
-            <a:off x="3474720" y="2926080"/>
+            <a:off x="3474720" y="2907792"/>
             <a:ext cx="2103120" cy="411480"/>
           </a:xfrm>
           <a:prstGeom prst="rect">
@@ -3435,7 +3435,7 @@
                 </a:solidFill>
                 <a:latin typeface="Microsoft YaHei"/>
               </a:rPr>
-              <a:t>????</a:t>
+              <a:t>深证成指</a:t>
             </a:r>
           </a:p>
         </p:txBody>
@@ -3470,7 +3470,7 @@
                 </a:solidFill>
                 <a:latin typeface="Microsoft YaHei"/>
               </a:rPr>
-              <a:t>?????????-2.21%</a:t>
+              <a:t>东方财富盘前展示：-2.21%</a:t>
             </a:r>
           </a:p>
         </p:txBody>
@@ -3528,7 +3528,7 @@
         </p:nvSpPr>
         <p:spPr>
           <a:xfrm>
-            <a:off x="6126480" y="2926080"/>
+            <a:off x="6126480" y="2907792"/>
             <a:ext cx="2103120" cy="411480"/>
           </a:xfrm>
           <a:prstGeom prst="rect">
@@ -3585,7 +3585,7 @@
                 </a:solidFill>
                 <a:latin typeface="Microsoft YaHei"/>
               </a:rPr>
-              <a:t>??????</a:t>
+              <a:t>主板短线约束</a:t>
             </a:r>
           </a:p>
         </p:txBody>
@@ -3620,7 +3620,7 @@
                 </a:solidFill>
                 <a:latin typeface="Microsoft YaHei"/>
               </a:rPr>
-              <a:t>???????????</a:t>
+              <a:t>只做触发，不做冲动追高</a:t>
             </a:r>
           </a:p>
         </p:txBody>
@@ -3634,7 +3634,7 @@
         <p:spPr>
           <a:xfrm>
             <a:off x="731520" y="4800600"/>
-            <a:ext cx="10515600" cy="594360"/>
+            <a:ext cx="10515600" cy="640080"/>
           </a:xfrm>
           <a:prstGeom prst="rect">
             <a:avLst/>
@@ -3651,11 +3651,11 @@
             <a:r>
               <a:rPr sz="1800" b="1">
                 <a:solidFill>
-                  <a:srgbClr val="FAFAFA"/>
-                </a:solidFill>
-                <a:latin typeface="Microsoft YaHei"/>
-              </a:rPr>
-              <a:t>?????6?8?????????????? + ?????????????????????????????????</a:t>
+                  <a:srgbClr val="FFFFFF"/>
+                </a:solidFill>
+                <a:latin typeface="Microsoft YaHei"/>
+              </a:rPr>
+              <a:t>结论先行：6月8日开盘前仍是“上一交易日数据 + 当日资讯催化”的环境，适合准备观察池，不适合把盘前观点当盘后定论。</a:t>
             </a:r>
           </a:p>
         </p:txBody>
@@ -3669,7 +3669,7 @@
         <p:spPr>
           <a:xfrm>
             <a:off x="594360" y="6446520"/>
-            <a:ext cx="9966960" cy="201168"/>
+            <a:ext cx="10012680" cy="228600"/>
           </a:xfrm>
           <a:prstGeom prst="rect">
             <a:avLst/>
@@ -3690,7 +3690,7 @@
                 </a:solidFill>
                 <a:latin typeface="Microsoft YaHei"/>
               </a:rPr>
-              <a:t>???????????published at 2026/6/8 7:22:02??????????? 2026-06-08 07:17-07:22 CST?</a:t>
+              <a:t>来源：东方财富网首页（published at 2026/6/8 7:22:02）与指数接口；访问时间 2026-06-08 07:17-07:22 CST。</a:t>
             </a:r>
           </a:p>
         </p:txBody>
@@ -3786,7 +3786,7 @@
                 </a:solidFill>
                 <a:latin typeface="Microsoft YaHei"/>
               </a:rPr>
-              <a:t>6?8??????</a:t>
+              <a:t>6月8日盘中检查表</a:t>
             </a:r>
           </a:p>
         </p:txBody>
@@ -3817,11 +3817,11 @@
             <a:r>
               <a:rPr sz="1600" b="0">
                 <a:solidFill>
-                  <a:srgbClr val="DCE0E2"/>
-                </a:solidFill>
-                <a:latin typeface="Microsoft YaHei"/>
-              </a:rPr>
-              <a:t>??????????????????????????????</a:t>
+                  <a:srgbClr val="E6EAEC"/>
+                </a:solidFill>
+                <a:latin typeface="Microsoft YaHei"/>
+              </a:rPr>
+              <a:t>先确认主线，再确认龙头，再确认买点。任何一项缺失，都不交易。</a:t>
             </a:r>
           </a:p>
         </p:txBody>
@@ -3936,7 +3936,7 @@
                 </a:solidFill>
                 <a:latin typeface="Microsoft YaHei"/>
               </a:rPr>
-              <a:t>????AI??/???/?????????????????</a:t>
+              <a:t>看竞价：AI硬件/机器人/电力哪条线最集中，候选股是否超预期</a:t>
             </a:r>
           </a:p>
         </p:txBody>
@@ -4051,7 +4051,7 @@
                 </a:solidFill>
                 <a:latin typeface="Microsoft YaHei"/>
               </a:rPr>
-              <a:t>????????????????????????</a:t>
+              <a:t>看承接：高开是否放量回落，低开是否快速收回均价线</a:t>
             </a:r>
           </a:p>
         </p:txBody>
@@ -4166,7 +4166,7 @@
                 </a:solidFill>
                 <a:latin typeface="Microsoft YaHei"/>
               </a:rPr>
-              <a:t>???????????2?????/????</a:t>
+              <a:t>看扩散：板块内是否出现2只以上涨停/强势封板</a:t>
             </a:r>
           </a:p>
         </p:txBody>
@@ -4281,7 +4281,7 @@
                 </a:solidFill>
                 <a:latin typeface="Microsoft YaHei"/>
               </a:rPr>
-              <a:t>??????????????????????????</a:t>
+              <a:t>看纪律：未爆发不加仓，跌破结构直接撤，盈利先兑现一半</a:t>
             </a:r>
           </a:p>
         </p:txBody>
@@ -4316,7 +4316,7 @@
                 </a:solidFill>
                 <a:latin typeface="Microsoft YaHei"/>
               </a:rPr>
-              <a:t>??????????????????????????????????????????????????</a:t>
+              <a:t>最终口径：永鼎股份、东方精工、明星电力进入盘前观察池；开盘后若主线不确认或形态不确认，宁可空仓等待。</a:t>
             </a:r>
           </a:p>
         </p:txBody>
@@ -4330,7 +4330,7 @@
         <p:spPr>
           <a:xfrm>
             <a:off x="594360" y="6446520"/>
-            <a:ext cx="9966960" cy="201168"/>
+            <a:ext cx="10012680" cy="228600"/>
           </a:xfrm>
           <a:prstGeom prst="rect">
             <a:avLst/>
@@ -4351,7 +4351,7 @@
                 </a:solidFill>
                 <a:latin typeface="Microsoft YaHei"/>
               </a:rPr>
-              <a:t>?????????????????????????????????????????????????</a:t>
+              <a:t>来源：东方财富网、用户方案文档。风险提示：短线交易高风险，报告不构成任何收益承诺或个性化投资建议。</a:t>
             </a:r>
           </a:p>
         </p:txBody>
@@ -4469,7 +4469,7 @@
         <p:spPr>
           <a:xfrm>
             <a:off x="777240" y="347472"/>
-            <a:ext cx="3657600" cy="274320"/>
+            <a:ext cx="4023360" cy="274320"/>
           </a:xfrm>
           <a:prstGeom prst="rect">
             <a:avLst/>
@@ -4504,7 +4504,7 @@
         <p:spPr>
           <a:xfrm>
             <a:off x="594360" y="749808"/>
-            <a:ext cx="10607040" cy="749808"/>
+            <a:ext cx="10698480" cy="749808"/>
           </a:xfrm>
           <a:prstGeom prst="rect">
             <a:avLst/>
@@ -4525,7 +4525,7 @@
                 </a:solidFill>
                 <a:latin typeface="Microsoft YaHei"/>
               </a:rPr>
-              <a:t>???????????????????????????</a:t>
+              <a:t>今天的任务不是预测全天，而是锁定开盘后最可能扩散的主线</a:t>
             </a:r>
           </a:p>
         </p:txBody>
@@ -4539,7 +4539,7 @@
         <p:spPr>
           <a:xfrm>
             <a:off x="621792" y="1444752"/>
-            <a:ext cx="10607040" cy="384048"/>
+            <a:ext cx="10698480" cy="384048"/>
           </a:xfrm>
           <a:prstGeom prst="rect">
             <a:avLst/>
@@ -4560,7 +4560,7 @@
                 </a:solidFill>
                 <a:latin typeface="Microsoft YaHei"/>
               </a:rPr>
-              <a:t>?????????????????????? + ???????????</a:t>
+              <a:t>盘前无法确认涨停梯队和资金流入，先用主线强度 + 承接形态建立交易预案。</a:t>
             </a:r>
           </a:p>
         </p:txBody>
@@ -4618,7 +4618,7 @@
         </p:nvSpPr>
         <p:spPr>
           <a:xfrm>
-            <a:off x="868680" y="2057400"/>
+            <a:off x="868680" y="2039112"/>
             <a:ext cx="2011680" cy="411480"/>
           </a:xfrm>
           <a:prstGeom prst="rect">
@@ -4640,7 +4640,7 @@
                 </a:solidFill>
                 <a:latin typeface="Microsoft YaHei"/>
               </a:rPr>
-              <a:t>???</a:t>
+              <a:t>弱修复</a:t>
             </a:r>
           </a:p>
         </p:txBody>
@@ -4675,7 +4675,7 @@
                 </a:solidFill>
                 <a:latin typeface="Microsoft YaHei"/>
               </a:rPr>
-              <a:t>????</a:t>
+              <a:t>指数环境</a:t>
             </a:r>
           </a:p>
         </p:txBody>
@@ -4710,7 +4710,7 @@
                 </a:solidFill>
                 <a:latin typeface="Microsoft YaHei"/>
               </a:rPr>
-              <a:t>??????????????????</a:t>
+              <a:t>上一交易日主要指数回落，短线仓位应轻</a:t>
             </a:r>
           </a:p>
         </p:txBody>
@@ -4768,7 +4768,7 @@
         </p:nvSpPr>
         <p:spPr>
           <a:xfrm>
-            <a:off x="3383279" y="2057400"/>
+            <a:off x="3383279" y="2039112"/>
             <a:ext cx="2011680" cy="411480"/>
           </a:xfrm>
           <a:prstGeom prst="rect">
@@ -4790,7 +4790,7 @@
                 </a:solidFill>
                 <a:latin typeface="Microsoft YaHei"/>
               </a:rPr>
-              <a:t>????</a:t>
+              <a:t>科技扩散</a:t>
             </a:r>
           </a:p>
         </p:txBody>
@@ -4825,7 +4825,7 @@
                 </a:solidFill>
                 <a:latin typeface="Microsoft YaHei"/>
               </a:rPr>
-              <a:t>????</a:t>
+              <a:t>资讯线索</a:t>
             </a:r>
           </a:p>
         </p:txBody>
@@ -4860,7 +4860,7 @@
                 </a:solidFill>
                 <a:latin typeface="Microsoft YaHei"/>
               </a:rPr>
-              <a:t>???????? AI ??/??????</a:t>
+              <a:t>东方财富首页出现 AI 浪潮/科技主题内容</a:t>
             </a:r>
           </a:p>
         </p:txBody>
@@ -4918,7 +4918,7 @@
         </p:nvSpPr>
         <p:spPr>
           <a:xfrm>
-            <a:off x="5897880" y="2057400"/>
+            <a:off x="5897880" y="2039112"/>
             <a:ext cx="2011680" cy="411480"/>
           </a:xfrm>
           <a:prstGeom prst="rect">
@@ -4940,7 +4940,7 @@
                 </a:solidFill>
                 <a:latin typeface="Microsoft YaHei"/>
               </a:rPr>
-              <a:t>????</a:t>
+              <a:t>主板优先</a:t>
             </a:r>
           </a:p>
         </p:txBody>
@@ -4975,7 +4975,7 @@
                 </a:solidFill>
                 <a:latin typeface="Microsoft YaHei"/>
               </a:rPr>
-              <a:t>????</a:t>
+              <a:t>制度选择</a:t>
             </a:r>
           </a:p>
         </p:txBody>
@@ -5010,7 +5010,7 @@
                 </a:solidFill>
                 <a:latin typeface="Microsoft YaHei"/>
               </a:rPr>
-              <a:t>10%????????????</a:t>
+              <a:t>10%涨跌幅，适合纪律型龙回头</a:t>
             </a:r>
           </a:p>
         </p:txBody>
@@ -5068,7 +5068,7 @@
         </p:nvSpPr>
         <p:spPr>
           <a:xfrm>
-            <a:off x="8412480" y="2057400"/>
+            <a:off x="8412480" y="2039112"/>
             <a:ext cx="2011680" cy="411480"/>
           </a:xfrm>
           <a:prstGeom prst="rect">
@@ -5090,7 +5090,7 @@
                 </a:solidFill>
                 <a:latin typeface="Microsoft YaHei"/>
               </a:rPr>
-              <a:t>????</a:t>
+              <a:t>右侧确认</a:t>
             </a:r>
           </a:p>
         </p:txBody>
@@ -5125,7 +5125,7 @@
                 </a:solidFill>
                 <a:latin typeface="Microsoft YaHei"/>
               </a:rPr>
-              <a:t>????</a:t>
+              <a:t>执行方式</a:t>
             </a:r>
           </a:p>
         </p:txBody>
@@ -5160,7 +5160,7 @@
                 </a:solidFill>
                 <a:latin typeface="Microsoft YaHei"/>
               </a:rPr>
-              <a:t>???????????</a:t>
+              <a:t>不抢一字，不接放量破位</a:t>
             </a:r>
           </a:p>
         </p:txBody>
@@ -5262,7 +5262,7 @@
         <p:spPr>
           <a:xfrm>
             <a:off x="978408" y="3803904"/>
-            <a:ext cx="4480560" cy="274320"/>
+            <a:ext cx="4434840" cy="310896"/>
           </a:xfrm>
           <a:prstGeom prst="rect">
             <a:avLst/>
@@ -5283,7 +5283,7 @@
                 </a:solidFill>
                 <a:latin typeface="Microsoft YaHei"/>
               </a:rPr>
-              <a:t>??????</a:t>
+              <a:t>盘前主线候选</a:t>
             </a:r>
           </a:p>
         </p:txBody>
@@ -5296,7 +5296,7 @@
         </p:nvSpPr>
         <p:spPr>
           <a:xfrm>
-            <a:off x="978408" y="4160520"/>
+            <a:off x="978408" y="4187952"/>
             <a:ext cx="4434840" cy="1170431"/>
           </a:xfrm>
           <a:prstGeom prst="rect">
@@ -5312,15 +5312,15 @@
           <a:p>
             <a:pPr algn="l"/>
             <a:r>
-              <a:rPr sz="1110" b="0">
+              <a:rPr sz="1100" b="0">
                 <a:solidFill>
                   <a:srgbClr val="606970"/>
                 </a:solidFill>
                 <a:latin typeface="Microsoft YaHei"/>
               </a:rPr>
-              <a:t>? AI??/?????AI????????????????????
-? ???/?????????????????????????
-? ??/????????????????????????</a:t>
+              <a:t>• AI算力/光通信：受AI浪潮持续扩散资讯催化，关注硬件链条承接。
+• 机器人/设备更新：政策和产业趋势反复活跃，适合找弹性龙头。
+• 电力/能源安全：防御与事件催化并存，适合指数弱时观察。</a:t>
             </a:r>
           </a:p>
         </p:txBody>
@@ -5422,7 +5422,7 @@
         <p:spPr>
           <a:xfrm>
             <a:off x="6190488" y="3803904"/>
-            <a:ext cx="4480560" cy="274320"/>
+            <a:ext cx="4434840" cy="310896"/>
           </a:xfrm>
           <a:prstGeom prst="rect">
             <a:avLst/>
@@ -5443,7 +5443,7 @@
                 </a:solidFill>
                 <a:latin typeface="Microsoft YaHei"/>
               </a:rPr>
-              <a:t>??????</a:t>
+              <a:t>盘中确认顺序</a:t>
             </a:r>
           </a:p>
         </p:txBody>
@@ -5456,7 +5456,7 @@
         </p:nvSpPr>
         <p:spPr>
           <a:xfrm>
-            <a:off x="6190488" y="4160520"/>
+            <a:off x="6190488" y="4187952"/>
             <a:ext cx="4434840" cy="1170431"/>
           </a:xfrm>
           <a:prstGeom prst="rect">
@@ -5472,15 +5472,15 @@
           <a:p>
             <a:pPr algn="l"/>
             <a:r>
-              <a:rPr sz="1110" b="0">
+              <a:rPr sz="1100" b="0">
                 <a:solidFill>
                   <a:srgbClr val="606970"/>
                 </a:solidFill>
                 <a:latin typeface="Microsoft YaHei"/>
               </a:rPr>
-              <a:t>? ??????????????????????
-? ??????????????????????
-? ??????10/20????????????????</a:t>
+              <a:t>• 先看涨停家数与最高连板高度；跌停放大则降仓。
+• 主线板块内谁先回封、谁最抗跌，才有龙头资格。
+• 个股必须接近10/20日线止跌或放量突破关键阴线高点。</a:t>
             </a:r>
           </a:p>
         </p:txBody>
@@ -5494,7 +5494,7 @@
         <p:spPr>
           <a:xfrm>
             <a:off x="594360" y="6446520"/>
-            <a:ext cx="9966960" cy="201168"/>
+            <a:ext cx="10012680" cy="228600"/>
           </a:xfrm>
           <a:prstGeom prst="rect">
             <a:avLst/>
@@ -5515,7 +5515,7 @@
                 </a:solidFill>
                 <a:latin typeface="Microsoft YaHei"/>
               </a:rPr>
-              <a:t>??????????????????????????? 2026-06-08 07:17-07:22 CST??????????????</a:t>
+              <a:t>来源：东方财富网首页与指数接口、用户方案文档；访问时间 2026-06-08 07:17-07:22 CST。仅作研究，不构成投资建议。</a:t>
             </a:r>
           </a:p>
         </p:txBody>
@@ -5633,7 +5633,7 @@
         <p:spPr>
           <a:xfrm>
             <a:off x="777240" y="347472"/>
-            <a:ext cx="3657600" cy="274320"/>
+            <a:ext cx="4023360" cy="274320"/>
           </a:xfrm>
           <a:prstGeom prst="rect">
             <a:avLst/>
@@ -5668,7 +5668,7 @@
         <p:spPr>
           <a:xfrm>
             <a:off x="594360" y="749808"/>
-            <a:ext cx="10607040" cy="749808"/>
+            <a:ext cx="10698480" cy="749808"/>
           </a:xfrm>
           <a:prstGeom prst="rect">
             <a:avLst/>
@@ -5689,7 +5689,7 @@
                 </a:solidFill>
                 <a:latin typeface="Microsoft YaHei"/>
               </a:rPr>
-              <a:t>???????????????????????????</a:t>
+              <a:t>方案的核心不是“买股票”，而是只在热点龙头二波里等确认</a:t>
             </a:r>
           </a:p>
         </p:txBody>
@@ -5703,7 +5703,7 @@
         <p:spPr>
           <a:xfrm>
             <a:off x="621792" y="1444752"/>
-            <a:ext cx="10607040" cy="384048"/>
+            <a:ext cx="10698480" cy="384048"/>
           </a:xfrm>
           <a:prstGeom prst="rect">
             <a:avLst/>
@@ -5724,7 +5724,7 @@
                 </a:solidFill>
                 <a:latin typeface="Microsoft YaHei"/>
               </a:rPr>
-              <a:t>??????????? -&gt; ??? -&gt; ???? -&gt; ?????? -&gt; ?????</a:t>
+              <a:t>从方案文档抽取：选热点 -&gt; 挑龙头 -&gt; 缩量低吸 -&gt; 放量右侧加仓 -&gt; 止损止盈。</a:t>
             </a:r>
           </a:p>
         </p:txBody>
@@ -5839,7 +5839,7 @@
                 </a:solidFill>
                 <a:latin typeface="Microsoft YaHei"/>
               </a:rPr>
-              <a:t>1 ????</a:t>
+              <a:t>1 主流题材</a:t>
             </a:r>
           </a:p>
         </p:txBody>
@@ -5874,7 +5874,7 @@
                 </a:solidFill>
                 <a:latin typeface="Microsoft YaHei"/>
               </a:rPr>
-              <a:t>??????????????????????2-3??</a:t>
+              <a:t>政策驱动、产业突破、资金持续净流入；只看最强2-3条线</a:t>
             </a:r>
           </a:p>
         </p:txBody>
@@ -5989,7 +5989,7 @@
                 </a:solidFill>
                 <a:latin typeface="Microsoft YaHei"/>
               </a:rPr>
-              <a:t>2 ?????</a:t>
+              <a:t>2 龙头辨识度</a:t>
             </a:r>
           </a:p>
         </p:txBody>
@@ -6024,7 +6024,7 @@
                 </a:solidFill>
                 <a:latin typeface="Microsoft YaHei"/>
               </a:rPr>
-              <a:t>??2-3?????????????????</a:t>
+              <a:t>前期2-3个强势连板或板块内最早、最坚决封板</a:t>
             </a:r>
           </a:p>
         </p:txBody>
@@ -6139,7 +6139,7 @@
                 </a:solidFill>
                 <a:latin typeface="Microsoft YaHei"/>
               </a:rPr>
-              <a:t>3 ????</a:t>
+              <a:t>3 缩量回踩</a:t>
             </a:r>
           </a:p>
         </p:txBody>
@@ -6174,7 +6174,7 @@
                 </a:solidFill>
                 <a:latin typeface="Microsoft YaHei"/>
               </a:rPr>
-              <a:t>??3-8?????20%-30%???????</a:t>
+              <a:t>回调3-8日，幅度约20%-30%，量能显著萎缩</a:t>
             </a:r>
           </a:p>
         </p:txBody>
@@ -6289,7 +6289,7 @@
                 </a:solidFill>
                 <a:latin typeface="Microsoft YaHei"/>
               </a:rPr>
-              <a:t>4 ????</a:t>
+              <a:t>4 右侧买点</a:t>
             </a:r>
           </a:p>
         </p:txBody>
@@ -6324,7 +6324,7 @@
                 </a:solidFill>
                 <a:latin typeface="Microsoft YaHei"/>
               </a:rPr>
-              <a:t>10/20????????????????</a:t>
+              <a:t>10/20日线止跌，或放量突破关键阴线高点</a:t>
             </a:r>
           </a:p>
         </p:txBody>
@@ -6439,7 +6439,7 @@
                 </a:solidFill>
                 <a:latin typeface="Microsoft YaHei"/>
               </a:rPr>
-              <a:t>5 ????</a:t>
+              <a:t>5 铁血纪律</a:t>
             </a:r>
           </a:p>
         </p:txBody>
@@ -6474,7 +6474,7 @@
                 </a:solidFill>
                 <a:latin typeface="Microsoft YaHei"/>
               </a:rPr>
-              <a:t>??&lt;50%?-3%~-5%???5%~10%?????</a:t>
+              <a:t>单股&lt;50%，-3%~-5%止损，5%~10%先落袋一半</a:t>
             </a:r>
           </a:p>
         </p:txBody>
@@ -6509,7 +6509,7 @@
                 </a:solidFill>
                 <a:latin typeface="Microsoft YaHei"/>
               </a:rPr>
-              <a:t>????????? + ?????????????????????????????????????</a:t>
+              <a:t>本报告只给“观察池 + 触发条件”。若开盘后题材不在涨幅榜前列、个股无量反抽或跌破结构，直接剔除。</a:t>
             </a:r>
           </a:p>
         </p:txBody>
@@ -6523,7 +6523,7 @@
         <p:spPr>
           <a:xfrm>
             <a:off x="594360" y="6446520"/>
-            <a:ext cx="9966960" cy="201168"/>
+            <a:ext cx="10012680" cy="228600"/>
           </a:xfrm>
           <a:prstGeom prst="rect">
             <a:avLst/>
@@ -6544,7 +6544,7 @@
                 </a:solidFill>
                 <a:latin typeface="Microsoft YaHei"/>
               </a:rPr>
-              <a:t>??????????????????????????? 2026-06-08 07:17-07:22 CST??????????????</a:t>
+              <a:t>来源：东方财富网首页与指数接口、用户方案文档；访问时间 2026-06-08 07:17-07:22 CST。仅作研究，不构成投资建议。</a:t>
             </a:r>
           </a:p>
         </p:txBody>
@@ -6662,7 +6662,7 @@
         <p:spPr>
           <a:xfrm>
             <a:off x="777240" y="347472"/>
-            <a:ext cx="3657600" cy="274320"/>
+            <a:ext cx="4023360" cy="274320"/>
           </a:xfrm>
           <a:prstGeom prst="rect">
             <a:avLst/>
@@ -6697,7 +6697,7 @@
         <p:spPr>
           <a:xfrm>
             <a:off x="594360" y="749808"/>
-            <a:ext cx="10607040" cy="749808"/>
+            <a:ext cx="10698480" cy="749808"/>
           </a:xfrm>
           <a:prstGeom prst="rect">
             <a:avLst/>
@@ -6718,7 +6718,7 @@
                 </a:solidFill>
                 <a:latin typeface="Microsoft YaHei"/>
               </a:rPr>
-              <a:t>?????????????????????????????</a:t>
+              <a:t>三只观察股来自同一个漏斗：主线、主板、弹性、回踩、右侧信号</a:t>
             </a:r>
           </a:p>
         </p:txBody>
@@ -6732,7 +6732,7 @@
         <p:spPr>
           <a:xfrm>
             <a:off x="621792" y="1444752"/>
-            <a:ext cx="10607040" cy="384048"/>
+            <a:ext cx="10698480" cy="384048"/>
           </a:xfrm>
           <a:prstGeom prst="rect">
             <a:avLst/>
@@ -6753,7 +6753,7 @@
                 </a:solidFill>
                 <a:latin typeface="Microsoft YaHei"/>
               </a:rPr>
-              <a:t>???????????6?8???????????????</a:t>
+              <a:t>盘前版本不依赖未发生的6月8日涨停数据，盘中必须二次校验。</a:t>
             </a:r>
           </a:p>
         </p:txBody>
@@ -6855,7 +6855,7 @@
         <p:spPr>
           <a:xfrm>
             <a:off x="978408" y="1975104"/>
-            <a:ext cx="3017520" cy="274320"/>
+            <a:ext cx="2971800" cy="310896"/>
           </a:xfrm>
           <a:prstGeom prst="rect">
             <a:avLst/>
@@ -6876,7 +6876,7 @@
                 </a:solidFill>
                 <a:latin typeface="Microsoft YaHei"/>
               </a:rPr>
-              <a:t>????</a:t>
+              <a:t>必须满足</a:t>
             </a:r>
           </a:p>
         </p:txBody>
@@ -6889,7 +6889,7 @@
         </p:nvSpPr>
         <p:spPr>
           <a:xfrm>
-            <a:off x="978408" y="2331720"/>
+            <a:off x="978408" y="2359152"/>
             <a:ext cx="2971800" cy="2450591"/>
           </a:xfrm>
           <a:prstGeom prst="rect">
@@ -6905,17 +6905,17 @@
           <a:p>
             <a:pPr algn="l"/>
             <a:r>
-              <a:rPr sz="1110" b="0">
+              <a:rPr sz="1100" b="0">
                 <a:solidFill>
                   <a:srgbClr val="606970"/>
                 </a:solidFill>
                 <a:latin typeface="Microsoft YaHei"/>
               </a:rPr>
-              <a:t>? ??????ST?10%????
-? ???????????????????
-? ????????????????
-? ??????????10/20?????
-? ????????????????</a:t>
+              <a:t>• 沪深主板，非ST，10%涨跌幅。
+• 处于当日最强主线之一，最好有板块联动。
+• 前期有辨识度，不是长期阴跌反抽。
+• 回踩不放量破位，仍在10/20日线附近。
+• 买点只能来自止跌小阳或放量突破。</a:t>
             </a:r>
           </a:p>
         </p:txBody>
@@ -7017,7 +7017,7 @@
         <p:spPr>
           <a:xfrm>
             <a:off x="4636007" y="1975104"/>
-            <a:ext cx="3017520" cy="274320"/>
+            <a:ext cx="2971800" cy="310896"/>
           </a:xfrm>
           <a:prstGeom prst="rect">
             <a:avLst/>
@@ -7038,7 +7038,7 @@
                 </a:solidFill>
                 <a:latin typeface="Microsoft YaHei"/>
               </a:rPr>
-              <a:t>????</a:t>
+              <a:t>一票否决</a:t>
             </a:r>
           </a:p>
         </p:txBody>
@@ -7051,7 +7051,7 @@
         </p:nvSpPr>
         <p:spPr>
           <a:xfrm>
-            <a:off x="4636007" y="2331720"/>
+            <a:off x="4636007" y="2359152"/>
             <a:ext cx="2971800" cy="2450591"/>
           </a:xfrm>
           <a:prstGeom prst="rect">
@@ -7067,17 +7067,17 @@
           <a:p>
             <a:pPr algn="l"/>
             <a:r>
-              <a:rPr sz="1110" b="0">
+              <a:rPr sz="1100" b="0">
                 <a:solidFill>
                   <a:srgbClr val="606970"/>
                 </a:solidFill>
                 <a:latin typeface="Microsoft YaHei"/>
               </a:rPr>
-              <a:t>? ??????????????????
-? ????10??/???????
-? ???????????????
-? ???????????????????
-? ????-3%~-5%?????</a:t>
+              <a:t>• 开盘板块低于市场平均，个股孤立上涨。
+• 放量跌破10日线/前大阳线低点。
+• 高开秒板后开板爆量且回封无力。
+• 流通盘过大弹性不足，或过小流动性不足。
+• 亏损触发-3%~-5%仍想补仓。</a:t>
             </a:r>
           </a:p>
         </p:txBody>
@@ -7179,7 +7179,7 @@
         <p:spPr>
           <a:xfrm>
             <a:off x="8293608" y="1975104"/>
-            <a:ext cx="3017520" cy="274320"/>
+            <a:ext cx="2971800" cy="310896"/>
           </a:xfrm>
           <a:prstGeom prst="rect">
             <a:avLst/>
@@ -7200,7 +7200,7 @@
                 </a:solidFill>
                 <a:latin typeface="Microsoft YaHei"/>
               </a:rPr>
-              <a:t>????</a:t>
+              <a:t>仓位动作</a:t>
             </a:r>
           </a:p>
         </p:txBody>
@@ -7213,7 +7213,7 @@
         </p:nvSpPr>
         <p:spPr>
           <a:xfrm>
-            <a:off x="8293608" y="2331720"/>
+            <a:off x="8293608" y="2359152"/>
             <a:ext cx="2971800" cy="2450591"/>
           </a:xfrm>
           <a:prstGeom prst="rect">
@@ -7229,17 +7229,17 @@
           <a:p>
             <a:pPr algn="l"/>
             <a:r>
-              <a:rPr sz="1110" b="0">
+              <a:rPr sz="1100" b="0">
                 <a:solidFill>
                   <a:srgbClr val="606970"/>
                 </a:solidFill>
                 <a:latin typeface="Microsoft YaHei"/>
               </a:rPr>
-              <a:t>? ????30%????
-? ???????????
-? ???????????50%?
-? ??5%~10%??????
-? 3???????????????</a:t>
+              <a:t>• 首笔只做30%观察仓。
+• 右侧确认后再补确认仓。
+• 单股总仓不超过短线资金50%。
+• 盈利5%~10%先止盈一半。
+• 3天不爆发且结构走坏，释放资金。</a:t>
             </a:r>
           </a:p>
         </p:txBody>
@@ -7253,7 +7253,7 @@
         <p:spPr>
           <a:xfrm>
             <a:off x="594360" y="6446520"/>
-            <a:ext cx="9966960" cy="201168"/>
+            <a:ext cx="10012680" cy="228600"/>
           </a:xfrm>
           <a:prstGeom prst="rect">
             <a:avLst/>
@@ -7274,7 +7274,7 @@
                 </a:solidFill>
                 <a:latin typeface="Microsoft YaHei"/>
               </a:rPr>
-              <a:t>??????????????????????????? 2026-06-08 07:17-07:22 CST??????????????</a:t>
+              <a:t>来源：东方财富网首页与指数接口、用户方案文档；访问时间 2026-06-08 07:17-07:22 CST。仅作研究，不构成投资建议。</a:t>
             </a:r>
           </a:p>
         </p:txBody>
@@ -7392,7 +7392,7 @@
         <p:spPr>
           <a:xfrm>
             <a:off x="777240" y="347472"/>
-            <a:ext cx="3657600" cy="274320"/>
+            <a:ext cx="4023360" cy="274320"/>
           </a:xfrm>
           <a:prstGeom prst="rect">
             <a:avLst/>
@@ -7427,7 +7427,7 @@
         <p:spPr>
           <a:xfrm>
             <a:off x="594360" y="749808"/>
-            <a:ext cx="10607040" cy="749808"/>
+            <a:ext cx="10698480" cy="749808"/>
           </a:xfrm>
           <a:prstGeom prst="rect">
             <a:avLst/>
@@ -7448,7 +7448,7 @@
                 </a:solidFill>
                 <a:latin typeface="Microsoft YaHei"/>
               </a:rPr>
-              <a:t>?????????????AI??????????????</a:t>
+              <a:t>盘前观察池：三只股分别对应AI硬件、机器人、电力设备三条线</a:t>
             </a:r>
           </a:p>
         </p:txBody>
@@ -7462,7 +7462,7 @@
         <p:spPr>
           <a:xfrm>
             <a:off x="621792" y="1444752"/>
-            <a:ext cx="10607040" cy="384048"/>
+            <a:ext cx="10698480" cy="384048"/>
           </a:xfrm>
           <a:prstGeom prst="rect">
             <a:avLst/>
@@ -7483,7 +7483,7 @@
                 </a:solidFill>
                 <a:latin typeface="Microsoft YaHei"/>
               </a:rPr>
-              <a:t>????????????????????????????????</a:t>
+              <a:t>它们不是“开盘就买”的名单，而是满足方案条件后才允许执行的候选。</a:t>
             </a:r>
           </a:p>
         </p:txBody>
@@ -7542,7 +7542,7 @@
         <p:spPr>
           <a:xfrm>
             <a:off x="822960" y="1929384"/>
-            <a:ext cx="1005840" cy="201168"/>
+            <a:ext cx="1005840" cy="219456"/>
           </a:xfrm>
           <a:prstGeom prst="rect">
             <a:avLst/>
@@ -7563,7 +7563,7 @@
                 </a:solidFill>
                 <a:latin typeface="Microsoft YaHei"/>
               </a:rPr>
-              <a:t>??</a:t>
+              <a:t>股票</a:t>
             </a:r>
           </a:p>
         </p:txBody>
@@ -7577,7 +7577,7 @@
         <p:spPr>
           <a:xfrm>
             <a:off x="2011680" y="1929384"/>
-            <a:ext cx="822960" cy="201168"/>
+            <a:ext cx="822960" cy="219456"/>
           </a:xfrm>
           <a:prstGeom prst="rect">
             <a:avLst/>
@@ -7598,7 +7598,7 @@
                 </a:solidFill>
                 <a:latin typeface="Microsoft YaHei"/>
               </a:rPr>
-              <a:t>??</a:t>
+              <a:t>代码</a:t>
             </a:r>
           </a:p>
         </p:txBody>
@@ -7612,7 +7612,7 @@
         <p:spPr>
           <a:xfrm>
             <a:off x="3063240" y="1929384"/>
-            <a:ext cx="1417320" cy="201168"/>
+            <a:ext cx="1417320" cy="219456"/>
           </a:xfrm>
           <a:prstGeom prst="rect">
             <a:avLst/>
@@ -7633,7 +7633,7 @@
                 </a:solidFill>
                 <a:latin typeface="Microsoft YaHei"/>
               </a:rPr>
-              <a:t>??</a:t>
+              <a:t>主线</a:t>
             </a:r>
           </a:p>
         </p:txBody>
@@ -7647,7 +7647,7 @@
         <p:spPr>
           <a:xfrm>
             <a:off x="4846320" y="1929384"/>
-            <a:ext cx="2651760" cy="201168"/>
+            <a:ext cx="2651760" cy="219456"/>
           </a:xfrm>
           <a:prstGeom prst="rect">
             <a:avLst/>
@@ -7668,7 +7668,7 @@
                 </a:solidFill>
                 <a:latin typeface="Microsoft YaHei"/>
               </a:rPr>
-              <a:t>????</a:t>
+              <a:t>入池理由</a:t>
             </a:r>
           </a:p>
         </p:txBody>
@@ -7682,7 +7682,7 @@
         <p:spPr>
           <a:xfrm>
             <a:off x="7863840" y="1929384"/>
-            <a:ext cx="3200400" cy="201168"/>
+            <a:ext cx="3200400" cy="219456"/>
           </a:xfrm>
           <a:prstGeom prst="rect">
             <a:avLst/>
@@ -7703,7 +7703,7 @@
                 </a:solidFill>
                 <a:latin typeface="Microsoft YaHei"/>
               </a:rPr>
-              <a:t>????</a:t>
+              <a:t>触发条件</a:t>
             </a:r>
           </a:p>
         </p:txBody>
@@ -7783,7 +7783,7 @@
                 </a:solidFill>
                 <a:latin typeface="Microsoft YaHei"/>
               </a:rPr>
-              <a:t>????</a:t>
+              <a:t>永鼎股份</a:t>
             </a:r>
           </a:p>
         </p:txBody>
@@ -7853,7 +7853,7 @@
                 </a:solidFill>
                 <a:latin typeface="Microsoft YaHei"/>
               </a:rPr>
-              <a:t>AI?? / ???</a:t>
+              <a:t>AI算力 / 光通信</a:t>
             </a:r>
           </a:p>
         </p:txBody>
@@ -7888,7 +7888,7 @@
                 </a:solidFill>
                 <a:latin typeface="Microsoft YaHei"/>
               </a:rPr>
-              <a:t>????AI???????????</a:t>
+              <a:t>主题贴近AI硬件扩散，主板弹性观察</a:t>
             </a:r>
           </a:p>
         </p:txBody>
@@ -7923,7 +7923,7 @@
                 </a:solidFill>
                 <a:latin typeface="Microsoft YaHei"/>
               </a:rPr>
-              <a:t>?????10/20?????????????</a:t>
+              <a:t>等缩量靠近10/20日线，放量越过回踩阴线高点</a:t>
             </a:r>
           </a:p>
         </p:txBody>
@@ -8003,7 +8003,7 @@
                 </a:solidFill>
                 <a:latin typeface="Microsoft YaHei"/>
               </a:rPr>
-              <a:t>????</a:t>
+              <a:t>东方精工</a:t>
             </a:r>
           </a:p>
         </p:txBody>
@@ -8073,7 +8073,7 @@
                 </a:solidFill>
                 <a:latin typeface="Microsoft YaHei"/>
               </a:rPr>
-              <a:t>??? / ????</a:t>
+              <a:t>机器人 / 智能装备</a:t>
             </a:r>
           </a:p>
         </p:txBody>
@@ -8108,7 +8108,7 @@
                 </a:solidFill>
                 <a:latin typeface="Microsoft YaHei"/>
               </a:rPr>
-              <a:t>??????????????????</a:t>
+              <a:t>主板设备弹性，适合政策与产业催化轮动</a:t>
             </a:r>
           </a:p>
         </p:txBody>
@@ -8143,7 +8143,7 @@
                 </a:solidFill>
                 <a:latin typeface="Microsoft YaHei"/>
               </a:rPr>
-              <a:t>???????????????</a:t>
+              <a:t>等板块强度确认，止跌小阳后分批</a:t>
             </a:r>
           </a:p>
         </p:txBody>
@@ -8223,7 +8223,7 @@
                 </a:solidFill>
                 <a:latin typeface="Microsoft YaHei"/>
               </a:rPr>
-              <a:t>????</a:t>
+              <a:t>明星电力</a:t>
             </a:r>
           </a:p>
         </p:txBody>
@@ -8293,7 +8293,7 @@
                 </a:solidFill>
                 <a:latin typeface="Microsoft YaHei"/>
               </a:rPr>
-              <a:t>?? / ????</a:t>
+              <a:t>电力 / 能源安全</a:t>
             </a:r>
           </a:p>
         </p:txBody>
@@ -8328,7 +8328,7 @@
                 </a:solidFill>
                 <a:latin typeface="Microsoft YaHei"/>
               </a:rPr>
-              <a:t>???????+???????????</a:t>
+              <a:t>指数弱时具防御+事件弹性，主板属性清晰</a:t>
             </a:r>
           </a:p>
         </p:txBody>
@@ -8363,7 +8363,7 @@
                 </a:solidFill>
                 <a:latin typeface="Microsoft YaHei"/>
               </a:rPr>
-              <a:t>????????????????</a:t>
+              <a:t>只做回调低吸或放量回封，不追高开</a:t>
             </a:r>
           </a:p>
         </p:txBody>
@@ -8398,7 +8398,7 @@
                 </a:solidFill>
                 <a:latin typeface="Microsoft YaHei"/>
               </a:rPr>
-              <a:t>??????AI??????????????????????????????????????????????????</a:t>
+              <a:t>盘中优先级：AI硬件确认则永鼎股份优先；机器人扩散则东方精工优先；指数继续偏弱且电力逆势时，明星电力才有防守型机会。</a:t>
             </a:r>
           </a:p>
         </p:txBody>
@@ -8412,7 +8412,7 @@
         <p:spPr>
           <a:xfrm>
             <a:off x="594360" y="6446520"/>
-            <a:ext cx="9966960" cy="201168"/>
+            <a:ext cx="10012680" cy="228600"/>
           </a:xfrm>
           <a:prstGeom prst="rect">
             <a:avLst/>
@@ -8433,7 +8433,7 @@
                 </a:solidFill>
                 <a:latin typeface="Microsoft YaHei"/>
               </a:rPr>
-              <a:t>??????????????????????????? 2026-06-08 07:17-07:22 CST??????????????</a:t>
+              <a:t>来源：东方财富网首页与指数接口、用户方案文档；访问时间 2026-06-08 07:17-07:22 CST。仅作研究，不构成投资建议。</a:t>
             </a:r>
           </a:p>
         </p:txBody>
@@ -8551,7 +8551,7 @@
         <p:spPr>
           <a:xfrm>
             <a:off x="777240" y="347472"/>
-            <a:ext cx="3657600" cy="274320"/>
+            <a:ext cx="4023360" cy="274320"/>
           </a:xfrm>
           <a:prstGeom prst="rect">
             <a:avLst/>
@@ -8586,7 +8586,7 @@
         <p:spPr>
           <a:xfrm>
             <a:off x="594360" y="749808"/>
-            <a:ext cx="10607040" cy="749808"/>
+            <a:ext cx="10698480" cy="749808"/>
           </a:xfrm>
           <a:prstGeom prst="rect">
             <a:avLst/>
@@ -8607,7 +8607,7 @@
                 </a:solidFill>
                 <a:latin typeface="Microsoft YaHei"/>
               </a:rPr>
-              <a:t>???? 600105?AI??/???????????</a:t>
+              <a:t>永鼎股份 600105：AI算力/光通信线的弹性观察标的</a:t>
             </a:r>
           </a:p>
         </p:txBody>
@@ -8621,7 +8621,7 @@
         <p:spPr>
           <a:xfrm>
             <a:off x="621792" y="1444752"/>
-            <a:ext cx="10607040" cy="384048"/>
+            <a:ext cx="10698480" cy="384048"/>
           </a:xfrm>
           <a:prstGeom prst="rect">
             <a:avLst/>
@@ -8642,7 +8642,7 @@
                 </a:solidFill>
                 <a:latin typeface="Microsoft YaHei"/>
               </a:rPr>
-              <a:t>??????????????????????????</a:t>
+              <a:t>只在条件触发时执行；未触发时保留现金是交易的一部分。</a:t>
             </a:r>
           </a:p>
         </p:txBody>
@@ -8744,7 +8744,7 @@
         <p:spPr>
           <a:xfrm>
             <a:off x="1024128" y="1975104"/>
-            <a:ext cx="4526280" cy="274320"/>
+            <a:ext cx="4480560" cy="310896"/>
           </a:xfrm>
           <a:prstGeom prst="rect">
             <a:avLst/>
@@ -8765,7 +8765,7 @@
                 </a:solidFill>
                 <a:latin typeface="Microsoft YaHei"/>
               </a:rPr>
-              <a:t>?????</a:t>
+              <a:t>为什么入池</a:t>
             </a:r>
           </a:p>
         </p:txBody>
@@ -8778,7 +8778,7 @@
         </p:nvSpPr>
         <p:spPr>
           <a:xfrm>
-            <a:off x="1024128" y="2331720"/>
+            <a:off x="1024128" y="2359152"/>
             <a:ext cx="4480560" cy="1993391"/>
           </a:xfrm>
           <a:prstGeom prst="rect">
@@ -8794,15 +8794,15 @@
           <a:p>
             <a:pPr algn="l"/>
             <a:r>
-              <a:rPr sz="1110" b="0">
+              <a:rPr sz="1100" b="0">
                 <a:solidFill>
                   <a:srgbClr val="606970"/>
                 </a:solidFill>
                 <a:latin typeface="Microsoft YaHei"/>
               </a:rPr>
-              <a:t>? AI????????????????????
-? ??????10%??????????????????
-? ?CPO??????????????????????????</a:t>
+              <a:t>• AI硬件链是盘前资讯里最容易扩散的科技方向。
+• 主板属性符合10%交易框架，适合用纪律型右侧信号处理。
+• 若CPO、光模块、通信设备联动走强，它具备被资金挖掘的空间。</a:t>
             </a:r>
           </a:p>
         </p:txBody>
@@ -8904,7 +8904,7 @@
         <p:spPr>
           <a:xfrm>
             <a:off x="6281928" y="1975104"/>
-            <a:ext cx="4526280" cy="274320"/>
+            <a:ext cx="4480560" cy="310896"/>
           </a:xfrm>
           <a:prstGeom prst="rect">
             <a:avLst/>
@@ -8925,7 +8925,7 @@
                 </a:solidFill>
                 <a:latin typeface="Microsoft YaHei"/>
               </a:rPr>
-              <a:t>???????</a:t>
+              <a:t>买点与失效条件</a:t>
             </a:r>
           </a:p>
         </p:txBody>
@@ -8938,7 +8938,7 @@
         </p:nvSpPr>
         <p:spPr>
           <a:xfrm>
-            <a:off x="6281928" y="2331720"/>
+            <a:off x="6281928" y="2359152"/>
             <a:ext cx="4480560" cy="1993391"/>
           </a:xfrm>
           <a:prstGeom prst="rect">
@@ -8954,15 +8954,15 @@
           <a:p>
             <a:pPr algn="l"/>
             <a:r>
-              <a:rPr sz="1110" b="0">
+              <a:rPr sz="1100" b="0">
                 <a:solidFill>
                   <a:srgbClr val="606970"/>
                 </a:solidFill>
                 <a:latin typeface="Microsoft YaHei"/>
               </a:rPr>
-              <a:t>? ???????10/20????????????????
-? ??????????????????????????
-? ???????10????????????????</a:t>
+              <a:t>• 低吸：缩量回踩10/20日线附近，出现十字星或止跌小阳。
+• 右侧：放量突破最近一根关键阴线高点，且板块同步走强。
+• 失效：放量跌破10日线或开盘冲高回落吞没前日结构。</a:t>
             </a:r>
           </a:p>
         </p:txBody>
@@ -8997,7 +8997,7 @@
                 </a:solidFill>
                 <a:latin typeface="Microsoft YaHei"/>
               </a:rPr>
-              <a:t>????</a:t>
+              <a:t>执行口令</a:t>
             </a:r>
           </a:p>
         </p:txBody>
@@ -9075,7 +9075,7 @@
                 </a:solidFill>
                 <a:latin typeface="Microsoft YaHei"/>
               </a:rPr>
-              <a:t>?????</a:t>
+              <a:t>板块进前排</a:t>
             </a:r>
           </a:p>
         </p:txBody>
@@ -9153,7 +9153,7 @@
                 </a:solidFill>
                 <a:latin typeface="Microsoft YaHei"/>
               </a:rPr>
-              <a:t>????</a:t>
+              <a:t>缩量止跌</a:t>
             </a:r>
           </a:p>
         </p:txBody>
@@ -9231,7 +9231,7 @@
                 </a:solidFill>
                 <a:latin typeface="Microsoft YaHei"/>
               </a:rPr>
-              <a:t>????</a:t>
+              <a:t>放量突破</a:t>
             </a:r>
           </a:p>
         </p:txBody>
@@ -9309,7 +9309,7 @@
                 </a:solidFill>
                 <a:latin typeface="Microsoft YaHei"/>
               </a:rPr>
-              <a:t>??&lt;=50%</a:t>
+              <a:t>仓位&lt;=50%</a:t>
             </a:r>
           </a:p>
         </p:txBody>
@@ -9387,7 +9387,7 @@
                 </a:solidFill>
                 <a:latin typeface="Microsoft YaHei"/>
               </a:rPr>
-              <a:t>-3%~-5%??</a:t>
+              <a:t>-3%~-5%止损</a:t>
             </a:r>
           </a:p>
         </p:txBody>
@@ -9401,7 +9401,7 @@
         <p:spPr>
           <a:xfrm>
             <a:off x="594360" y="6446520"/>
-            <a:ext cx="9966960" cy="201168"/>
+            <a:ext cx="10012680" cy="228600"/>
           </a:xfrm>
           <a:prstGeom prst="rect">
             <a:avLst/>
@@ -9422,7 +9422,7 @@
                 </a:solidFill>
                 <a:latin typeface="Microsoft YaHei"/>
               </a:rPr>
-              <a:t>??????????????????????????? 2026-06-08 07:17-07:22 CST??????????????</a:t>
+              <a:t>来源：东方财富网首页与指数接口、用户方案文档；访问时间 2026-06-08 07:17-07:22 CST。仅作研究，不构成投资建议。</a:t>
             </a:r>
           </a:p>
         </p:txBody>
@@ -9540,7 +9540,7 @@
         <p:spPr>
           <a:xfrm>
             <a:off x="777240" y="347472"/>
-            <a:ext cx="3657600" cy="274320"/>
+            <a:ext cx="4023360" cy="274320"/>
           </a:xfrm>
           <a:prstGeom prst="rect">
             <a:avLst/>
@@ -9575,7 +9575,7 @@
         <p:spPr>
           <a:xfrm>
             <a:off x="594360" y="749808"/>
-            <a:ext cx="10607040" cy="749808"/>
+            <a:ext cx="10698480" cy="749808"/>
           </a:xfrm>
           <a:prstGeom prst="rect">
             <a:avLst/>
@@ -9596,7 +9596,7 @@
                 </a:solidFill>
                 <a:latin typeface="Microsoft YaHei"/>
               </a:rPr>
-              <a:t>???? 002611????/??????????????</a:t>
+              <a:t>东方精工 002611：机器人/智能装备线的主板回头观察标的</a:t>
             </a:r>
           </a:p>
         </p:txBody>
@@ -9610,7 +9610,7 @@
         <p:spPr>
           <a:xfrm>
             <a:off x="621792" y="1444752"/>
-            <a:ext cx="10607040" cy="384048"/>
+            <a:ext cx="10698480" cy="384048"/>
           </a:xfrm>
           <a:prstGeom prst="rect">
             <a:avLst/>
@@ -9631,7 +9631,7 @@
                 </a:solidFill>
                 <a:latin typeface="Microsoft YaHei"/>
               </a:rPr>
-              <a:t>??????????????????????????</a:t>
+              <a:t>只在条件触发时执行；未触发时保留现金是交易的一部分。</a:t>
             </a:r>
           </a:p>
         </p:txBody>
@@ -9733,7 +9733,7 @@
         <p:spPr>
           <a:xfrm>
             <a:off x="1024128" y="1975104"/>
-            <a:ext cx="4526280" cy="274320"/>
+            <a:ext cx="4480560" cy="310896"/>
           </a:xfrm>
           <a:prstGeom prst="rect">
             <a:avLst/>
@@ -9754,7 +9754,7 @@
                 </a:solidFill>
                 <a:latin typeface="Microsoft YaHei"/>
               </a:rPr>
-              <a:t>?????</a:t>
+              <a:t>为什么入池</a:t>
             </a:r>
           </a:p>
         </p:txBody>
@@ -9767,7 +9767,7 @@
         </p:nvSpPr>
         <p:spPr>
           <a:xfrm>
-            <a:off x="1024128" y="2331720"/>
+            <a:off x="1024128" y="2359152"/>
             <a:ext cx="4480560" cy="1993391"/>
           </a:xfrm>
           <a:prstGeom prst="rect">
@@ -9783,15 +9783,15 @@
           <a:p>
             <a:pPr algn="l"/>
             <a:r>
-              <a:rPr sz="1110" b="0">
+              <a:rPr sz="1100" b="0">
                 <a:solidFill>
                   <a:srgbClr val="606970"/>
                 </a:solidFill>
                 <a:latin typeface="Microsoft YaHei"/>
               </a:rPr>
-              <a:t>? ????????????????????
-? ?????????????????????????
-? ?????????????????????</a:t>
+              <a:t>• 机器人与设备更新容易在政策窗口反复轮动。
+• 公司处在智能制造链条，短线弹性通常强于大市值权重。
+• 适合观察“前期强势后缩量回踩”的二波结构。</a:t>
             </a:r>
           </a:p>
         </p:txBody>
@@ -9893,7 +9893,7 @@
         <p:spPr>
           <a:xfrm>
             <a:off x="6281928" y="1975104"/>
-            <a:ext cx="4526280" cy="274320"/>
+            <a:ext cx="4480560" cy="310896"/>
           </a:xfrm>
           <a:prstGeom prst="rect">
             <a:avLst/>
@@ -9914,7 +9914,7 @@
                 </a:solidFill>
                 <a:latin typeface="Microsoft YaHei"/>
               </a:rPr>
-              <a:t>???????</a:t>
+              <a:t>买点与失效条件</a:t>
             </a:r>
           </a:p>
         </p:txBody>
@@ -9927,7 +9927,7 @@
         </p:nvSpPr>
         <p:spPr>
           <a:xfrm>
-            <a:off x="6281928" y="2331720"/>
+            <a:off x="6281928" y="2359152"/>
             <a:ext cx="4480560" cy="1993391"/>
           </a:xfrm>
           <a:prstGeom prst="rect">
@@ -9943,15 +9943,15 @@
           <a:p>
             <a:pPr algn="l"/>
             <a:r>
-              <a:rPr sz="1110" b="0">
+              <a:rPr sz="1100" b="0">
                 <a:solidFill>
                   <a:srgbClr val="606970"/>
                 </a:solidFill>
                 <a:latin typeface="Microsoft YaHei"/>
               </a:rPr>
-              <a:t>? ????????????????????????
-? ??????????????????????
-? ????????????????????????</a:t>
+              <a:t>• 低吸：板块强度进入前排，个股缩量贴近均线并止跌。
+• 右侧：放量站回关键阴线高点，分时均价线不破。
+• 失效：题材无联动、个股孤立拉升或跌破前大阳低点。</a:t>
             </a:r>
           </a:p>
         </p:txBody>
@@ -9986,7 +9986,7 @@
                 </a:solidFill>
                 <a:latin typeface="Microsoft YaHei"/>
               </a:rPr>
-              <a:t>????</a:t>
+              <a:t>执行口令</a:t>
             </a:r>
           </a:p>
         </p:txBody>
@@ -10064,7 +10064,7 @@
                 </a:solidFill>
                 <a:latin typeface="Microsoft YaHei"/>
               </a:rPr>
-              <a:t>?????</a:t>
+              <a:t>板块进前排</a:t>
             </a:r>
           </a:p>
         </p:txBody>
@@ -10142,7 +10142,7 @@
                 </a:solidFill>
                 <a:latin typeface="Microsoft YaHei"/>
               </a:rPr>
-              <a:t>????</a:t>
+              <a:t>缩量止跌</a:t>
             </a:r>
           </a:p>
         </p:txBody>
@@ -10220,7 +10220,7 @@
                 </a:solidFill>
                 <a:latin typeface="Microsoft YaHei"/>
               </a:rPr>
-              <a:t>????</a:t>
+              <a:t>放量突破</a:t>
             </a:r>
           </a:p>
         </p:txBody>
@@ -10298,7 +10298,7 @@
                 </a:solidFill>
                 <a:latin typeface="Microsoft YaHei"/>
               </a:rPr>
-              <a:t>??&lt;=50%</a:t>
+              <a:t>仓位&lt;=50%</a:t>
             </a:r>
           </a:p>
         </p:txBody>
@@ -10376,7 +10376,7 @@
                 </a:solidFill>
                 <a:latin typeface="Microsoft YaHei"/>
               </a:rPr>
-              <a:t>-3%~-5%??</a:t>
+              <a:t>-3%~-5%止损</a:t>
             </a:r>
           </a:p>
         </p:txBody>
@@ -10390,7 +10390,7 @@
         <p:spPr>
           <a:xfrm>
             <a:off x="594360" y="6446520"/>
-            <a:ext cx="9966960" cy="201168"/>
+            <a:ext cx="10012680" cy="228600"/>
           </a:xfrm>
           <a:prstGeom prst="rect">
             <a:avLst/>
@@ -10411,7 +10411,7 @@
                 </a:solidFill>
                 <a:latin typeface="Microsoft YaHei"/>
               </a:rPr>
-              <a:t>??????????????????????????? 2026-06-08 07:17-07:22 CST??????????????</a:t>
+              <a:t>来源：东方财富网首页与指数接口、用户方案文档；访问时间 2026-06-08 07:17-07:22 CST。仅作研究，不构成投资建议。</a:t>
             </a:r>
           </a:p>
         </p:txBody>
@@ -10529,7 +10529,7 @@
         <p:spPr>
           <a:xfrm>
             <a:off x="777240" y="347472"/>
-            <a:ext cx="3657600" cy="274320"/>
+            <a:ext cx="4023360" cy="274320"/>
           </a:xfrm>
           <a:prstGeom prst="rect">
             <a:avLst/>
@@ -10564,7 +10564,7 @@
         <p:spPr>
           <a:xfrm>
             <a:off x="594360" y="749808"/>
-            <a:ext cx="10607040" cy="749808"/>
+            <a:ext cx="10698480" cy="749808"/>
           </a:xfrm>
           <a:prstGeom prst="rect">
             <a:avLst/>
@@ -10585,7 +10585,7 @@
                 </a:solidFill>
                 <a:latin typeface="Microsoft YaHei"/>
               </a:rPr>
-              <a:t>???? 600101???/??????????????</a:t>
+              <a:t>明星电力 600101：电力/能源安全线的防守弹性观察标的</a:t>
             </a:r>
           </a:p>
         </p:txBody>
@@ -10599,7 +10599,7 @@
         <p:spPr>
           <a:xfrm>
             <a:off x="621792" y="1444752"/>
-            <a:ext cx="10607040" cy="384048"/>
+            <a:ext cx="10698480" cy="384048"/>
           </a:xfrm>
           <a:prstGeom prst="rect">
             <a:avLst/>
@@ -10620,7 +10620,7 @@
                 </a:solidFill>
                 <a:latin typeface="Microsoft YaHei"/>
               </a:rPr>
-              <a:t>??????????????????????????</a:t>
+              <a:t>只在条件触发时执行；未触发时保留现金是交易的一部分。</a:t>
             </a:r>
           </a:p>
         </p:txBody>
@@ -10722,7 +10722,7 @@
         <p:spPr>
           <a:xfrm>
             <a:off x="1024128" y="1975104"/>
-            <a:ext cx="4526280" cy="274320"/>
+            <a:ext cx="4480560" cy="310896"/>
           </a:xfrm>
           <a:prstGeom prst="rect">
             <a:avLst/>
@@ -10743,7 +10743,7 @@
                 </a:solidFill>
                 <a:latin typeface="Microsoft YaHei"/>
               </a:rPr>
-              <a:t>?????</a:t>
+              <a:t>为什么入池</a:t>
             </a:r>
           </a:p>
         </p:txBody>
@@ -10756,7 +10756,7 @@
         </p:nvSpPr>
         <p:spPr>
           <a:xfrm>
-            <a:off x="1024128" y="2331720"/>
+            <a:off x="1024128" y="2359152"/>
             <a:ext cx="4480560" cy="1993391"/>
           </a:xfrm>
           <a:prstGeom prst="rect">
@@ -10772,15 +10772,15 @@
           <a:p>
             <a:pPr algn="l"/>
             <a:r>
-              <a:rPr sz="1110" b="0">
+              <a:rPr sz="1100" b="0">
                 <a:solidFill>
                   <a:srgbClr val="606970"/>
                 </a:solidFill>
                 <a:latin typeface="Microsoft YaHei"/>
               </a:rPr>
-              <a:t>? ???????????????????????
-? ?????????????????????
-? ????????????????????????</a:t>
+              <a:t>• 指数弱势时，电力与能源安全更容易承担防御资金。
+• 主板交易规则清晰，适合严格仓位和止损管理。
+• 若市场风险偏好下降，它可作为非科技线的备用观察。</a:t>
             </a:r>
           </a:p>
         </p:txBody>
@@ -10882,7 +10882,7 @@
         <p:spPr>
           <a:xfrm>
             <a:off x="6281928" y="1975104"/>
-            <a:ext cx="4526280" cy="274320"/>
+            <a:ext cx="4480560" cy="310896"/>
           </a:xfrm>
           <a:prstGeom prst="rect">
             <a:avLst/>
@@ -10903,7 +10903,7 @@
                 </a:solidFill>
                 <a:latin typeface="Microsoft YaHei"/>
               </a:rPr>
-              <a:t>???????</a:t>
+              <a:t>买点与失效条件</a:t>
             </a:r>
           </a:p>
         </p:txBody>
@@ -10916,7 +10916,7 @@
         </p:nvSpPr>
         <p:spPr>
           <a:xfrm>
-            <a:off x="6281928" y="2331720"/>
+            <a:off x="6281928" y="2359152"/>
             <a:ext cx="4480560" cy="1993391"/>
           </a:xfrm>
           <a:prstGeom prst="rect">
@@ -10932,15 +10932,15 @@
           <a:p>
             <a:pPr algn="l"/>
             <a:r>
-              <a:rPr sz="1110" b="0">
+              <a:rPr sz="1100" b="0">
                 <a:solidFill>
                   <a:srgbClr val="606970"/>
                 </a:solidFill>
                 <a:latin typeface="Microsoft YaHei"/>
               </a:rPr>
-              <a:t>? ?????????20??????????
-? ???????????????????????
-? ????????????????/?????????</a:t>
+              <a:t>• 低吸：缩量回踩不破20日线，盘中承接明显。
+• 右侧：放量回封或突破整理平台，板块内多股跟随。
+• 失效：高开低走、放量滞涨，或跌停/大阴数量明显放大。</a:t>
             </a:r>
           </a:p>
         </p:txBody>
@@ -10975,7 +10975,7 @@
                 </a:solidFill>
                 <a:latin typeface="Microsoft YaHei"/>
               </a:rPr>
-              <a:t>????</a:t>
+              <a:t>执行口令</a:t>
             </a:r>
           </a:p>
         </p:txBody>
@@ -11053,7 +11053,7 @@
                 </a:solidFill>
                 <a:latin typeface="Microsoft YaHei"/>
               </a:rPr>
-              <a:t>?????</a:t>
+              <a:t>板块进前排</a:t>
             </a:r>
           </a:p>
         </p:txBody>
@@ -11131,7 +11131,7 @@
                 </a:solidFill>
                 <a:latin typeface="Microsoft YaHei"/>
               </a:rPr>
-              <a:t>????</a:t>
+              <a:t>缩量止跌</a:t>
             </a:r>
           </a:p>
         </p:txBody>
@@ -11209,7 +11209,7 @@
                 </a:solidFill>
                 <a:latin typeface="Microsoft YaHei"/>
               </a:rPr>
-              <a:t>????</a:t>
+              <a:t>放量突破</a:t>
             </a:r>
           </a:p>
         </p:txBody>
@@ -11287,7 +11287,7 @@
                 </a:solidFill>
                 <a:latin typeface="Microsoft YaHei"/>
               </a:rPr>
-              <a:t>??&lt;=50%</a:t>
+              <a:t>仓位&lt;=50%</a:t>
             </a:r>
           </a:p>
         </p:txBody>
@@ -11365,7 +11365,7 @@
                 </a:solidFill>
                 <a:latin typeface="Microsoft YaHei"/>
               </a:rPr>
-              <a:t>-3%~-5%??</a:t>
+              <a:t>-3%~-5%止损</a:t>
             </a:r>
           </a:p>
         </p:txBody>
@@ -11379,7 +11379,7 @@
         <p:spPr>
           <a:xfrm>
             <a:off x="594360" y="6446520"/>
-            <a:ext cx="9966960" cy="201168"/>
+            <a:ext cx="10012680" cy="228600"/>
           </a:xfrm>
           <a:prstGeom prst="rect">
             <a:avLst/>
@@ -11400,7 +11400,7 @@
                 </a:solidFill>
                 <a:latin typeface="Microsoft YaHei"/>
               </a:rPr>
-              <a:t>??????????????????????????? 2026-06-08 07:17-07:22 CST??????????????</a:t>
+              <a:t>来源：东方财富网首页与指数接口、用户方案文档；访问时间 2026-06-08 07:17-07:22 CST。仅作研究，不构成投资建议。</a:t>
             </a:r>
           </a:p>
         </p:txBody>
@@ -11518,7 +11518,7 @@
         <p:spPr>
           <a:xfrm>
             <a:off x="777240" y="347472"/>
-            <a:ext cx="3657600" cy="274320"/>
+            <a:ext cx="4023360" cy="274320"/>
           </a:xfrm>
           <a:prstGeom prst="rect">
             <a:avLst/>
@@ -11553,7 +11553,7 @@
         <p:spPr>
           <a:xfrm>
             <a:off x="594360" y="749808"/>
-            <a:ext cx="10607040" cy="749808"/>
+            <a:ext cx="10698480" cy="749808"/>
           </a:xfrm>
           <a:prstGeom prst="rect">
             <a:avLst/>
@@ -11574,7 +11574,7 @@
                 </a:solidFill>
                 <a:latin typeface="Microsoft YaHei"/>
               </a:rPr>
-              <a:t>?????????????????????????</a:t>
+              <a:t>短线胜负不取决于选中三只，而取决于错了能不能马上撤</a:t>
             </a:r>
           </a:p>
         </p:txBody>
@@ -11588,7 +11588,7 @@
         <p:spPr>
           <a:xfrm>
             <a:off x="621792" y="1444752"/>
-            <a:ext cx="10607040" cy="384048"/>
+            <a:ext cx="10698480" cy="384048"/>
           </a:xfrm>
           <a:prstGeom prst="rect">
             <a:avLst/>
@@ -11609,7 +11609,7 @@
                 </a:solidFill>
                 <a:latin typeface="Microsoft YaHei"/>
               </a:rPr>
-              <a:t>????????????????????????</a:t>
+              <a:t>这套方案的边界要写在交易前，而不是亏损后再解释。</a:t>
             </a:r>
           </a:p>
         </p:txBody>
@@ -11667,7 +11667,7 @@
         </p:nvSpPr>
         <p:spPr>
           <a:xfrm>
-            <a:off x="960120" y="2011680"/>
+            <a:off x="960120" y="1993392"/>
             <a:ext cx="1965960" cy="411480"/>
           </a:xfrm>
           <a:prstGeom prst="rect">
@@ -11724,7 +11724,7 @@
                 </a:solidFill>
                 <a:latin typeface="Microsoft YaHei"/>
               </a:rPr>
-              <a:t>????</a:t>
+              <a:t>单股上限</a:t>
             </a:r>
           </a:p>
         </p:txBody>
@@ -11759,7 +11759,7 @@
                 </a:solidFill>
                 <a:latin typeface="Microsoft YaHei"/>
               </a:rPr>
-              <a:t>???????????</a:t>
+              <a:t>触发即执行，不主观拖延</a:t>
             </a:r>
           </a:p>
         </p:txBody>
@@ -11817,7 +11817,7 @@
         </p:nvSpPr>
         <p:spPr>
           <a:xfrm>
-            <a:off x="3703320" y="2011680"/>
+            <a:off x="3703320" y="1993392"/>
             <a:ext cx="1965960" cy="411480"/>
           </a:xfrm>
           <a:prstGeom prst="rect">
@@ -11874,7 +11874,7 @@
                 </a:solidFill>
                 <a:latin typeface="Microsoft YaHei"/>
               </a:rPr>
-              <a:t>???</a:t>
+              <a:t>观察仓</a:t>
             </a:r>
           </a:p>
         </p:txBody>
@@ -11909,7 +11909,7 @@
                 </a:solidFill>
                 <a:latin typeface="Microsoft YaHei"/>
               </a:rPr>
-              <a:t>???????????</a:t>
+              <a:t>触发即执行，不主观拖延</a:t>
             </a:r>
           </a:p>
         </p:txBody>
@@ -11967,7 +11967,7 @@
         </p:nvSpPr>
         <p:spPr>
           <a:xfrm>
-            <a:off x="6446520" y="2011680"/>
+            <a:off x="6446520" y="1993392"/>
             <a:ext cx="1965960" cy="411480"/>
           </a:xfrm>
           <a:prstGeom prst="rect">
@@ -12024,7 +12024,7 @@
                 </a:solidFill>
                 <a:latin typeface="Microsoft YaHei"/>
               </a:rPr>
-              <a:t>???</a:t>
+              <a:t>止损线</a:t>
             </a:r>
           </a:p>
         </p:txBody>
@@ -12059,7 +12059,7 @@
                 </a:solidFill>
                 <a:latin typeface="Microsoft YaHei"/>
               </a:rPr>
-              <a:t>???????????</a:t>
+              <a:t>触发即执行，不主观拖延</a:t>
             </a:r>
           </a:p>
         </p:txBody>
@@ -12117,7 +12117,7 @@
         </p:nvSpPr>
         <p:spPr>
           <a:xfrm>
-            <a:off x="9189720" y="2011680"/>
+            <a:off x="9189720" y="1993392"/>
             <a:ext cx="1965960" cy="411480"/>
           </a:xfrm>
           <a:prstGeom prst="rect">
@@ -12174,7 +12174,7 @@
                 </a:solidFill>
                 <a:latin typeface="Microsoft YaHei"/>
               </a:rPr>
-              <a:t>????</a:t>
+              <a:t>首段止盈</a:t>
             </a:r>
           </a:p>
         </p:txBody>
@@ -12209,7 +12209,7 @@
                 </a:solidFill>
                 <a:latin typeface="Microsoft YaHei"/>
               </a:rPr>
-              <a:t>???????????</a:t>
+              <a:t>触发即执行，不主观拖延</a:t>
             </a:r>
           </a:p>
         </p:txBody>
@@ -12311,7 +12311,7 @@
         <p:spPr>
           <a:xfrm>
             <a:off x="1024128" y="3849624"/>
-            <a:ext cx="4617720" cy="274320"/>
+            <a:ext cx="4572000" cy="310896"/>
           </a:xfrm>
           <a:prstGeom prst="rect">
             <a:avLst/>
@@ -12332,7 +12332,7 @@
                 </a:solidFill>
                 <a:latin typeface="Microsoft YaHei"/>
               </a:rPr>
-              <a:t>???????????</a:t>
+              <a:t>今天必须暂停交易的情况</a:t>
             </a:r>
           </a:p>
         </p:txBody>
@@ -12345,7 +12345,7 @@
         </p:nvSpPr>
         <p:spPr>
           <a:xfrm>
-            <a:off x="1024128" y="4206240"/>
+            <a:off x="1024128" y="4233672"/>
             <a:ext cx="4572000" cy="1033271"/>
           </a:xfrm>
           <a:prstGeom prst="rect">
@@ -12361,15 +12361,15 @@
           <a:p>
             <a:pPr algn="l"/>
             <a:r>
-              <a:rPr sz="1110" b="0">
+              <a:rPr sz="1100" b="0">
                 <a:solidFill>
                   <a:srgbClr val="606970"/>
                 </a:solidFill>
                 <a:latin typeface="Microsoft YaHei"/>
               </a:rPr>
-              <a:t>? ????????????????
-? ???????????????????
-? ????????????????????</a:t>
+              <a:t>• 两市跌停明显放大，最高连板下降。
+• 三条主线都没有板块效应，只是个股轮动。
+• 候选股高开过多、量能异常放大但回封无力。</a:t>
             </a:r>
           </a:p>
         </p:txBody>
@@ -12471,7 +12471,7 @@
         <p:spPr>
           <a:xfrm>
             <a:off x="6281928" y="3849624"/>
-            <a:ext cx="4617720" cy="274320"/>
+            <a:ext cx="4572000" cy="310896"/>
           </a:xfrm>
           <a:prstGeom prst="rect">
             <a:avLst/>
@@ -12492,7 +12492,7 @@
                 </a:solidFill>
                 <a:latin typeface="Microsoft YaHei"/>
               </a:rPr>
-              <a:t>?????????</a:t>
+              <a:t>今天允许出手的情况</a:t>
             </a:r>
           </a:p>
         </p:txBody>
@@ -12505,7 +12505,7 @@
         </p:nvSpPr>
         <p:spPr>
           <a:xfrm>
-            <a:off x="6281928" y="4206240"/>
+            <a:off x="6281928" y="4233672"/>
             <a:ext cx="4572000" cy="1033271"/>
           </a:xfrm>
           <a:prstGeom prst="rect">
@@ -12521,15 +12521,15 @@
           <a:p>
             <a:pPr algn="l"/>
             <a:r>
-              <a:rPr sz="1110" b="0">
+              <a:rPr sz="1100" b="0">
                 <a:solidFill>
                   <a:srgbClr val="606970"/>
                 </a:solidFill>
                 <a:latin typeface="Microsoft YaHei"/>
               </a:rPr>
-              <a:t>? ??????????????
-? ?????????????
-? ?????????????????????????</a:t>
+              <a:t>• 涨停原因高度集中，主线清晰。
+• 目标股回踩后不破关键支撑。
+• 右侧突破时有成交量、分时均价线和板块联动共同确认。</a:t>
             </a:r>
           </a:p>
         </p:txBody>
@@ -12543,7 +12543,7 @@
         <p:spPr>
           <a:xfrm>
             <a:off x="594360" y="6446520"/>
-            <a:ext cx="9966960" cy="201168"/>
+            <a:ext cx="10012680" cy="228600"/>
           </a:xfrm>
           <a:prstGeom prst="rect">
             <a:avLst/>
@@ -12564,7 +12564,7 @@
                 </a:solidFill>
                 <a:latin typeface="Microsoft YaHei"/>
               </a:rPr>
-              <a:t>??????????????????????????? 2026-06-08 07:17-07:22 CST??????????????</a:t>
+              <a:t>来源：东方财富网首页与指数接口、用户方案文档；访问时间 2026-06-08 07:17-07:22 CST。仅作研究，不构成投资建议。</a:t>
             </a:r>
           </a:p>
         </p:txBody>

</xml_diff>